<commit_message>
Correct main-survey dates to May-October 2025; align sampling description
Co-Authored-By: Claude Fable 5 <noreply@anthropic.com>
Claude-Session: https://claude.ai/code/session_019BJ4u1WYcsA14q2B552n7R
</commit_message>
<xml_diff>
--- a/projects/marvin-stress-trauma/istss_trauma_saturation_template.pptx
+++ b/projects/marvin-stress-trauma/istss_trauma_saturation_template.pptx
@@ -2287,7 +2287,7 @@
           <a:lstStyle/>
           <a:p>
             <a:r>
-              <a:t>The MaRVIN sample Salma presented: 1,774 adults surveyed January to March 2024; 1,729 answered the trauma inventory and enter this analysis. Six states: five conflict-affected — Benue, Borno, Enugu, Rivers, Sokoto — plus Ogun as a non-conflict comparison, which anchors the low end of the trauma gradient. Stratified multi-stage cluster design, 565 community clusters, community and IDP-camp settings. All analyses honor the design: state strata, community clusters, linearized variances.</a:t>
+              <a:t>The MaRVIN sample Salma presented: 1,774 adults surveyed May to October 2025; 1,729 answered the trauma inventory and enter this analysis. Six states: five conflict-affected — Benue, Borno, Enugu, Rivers, Sokoto — plus Ogun as a non-conflict comparison, which anchors the low end of the trauma gradient. Stratified multi-stage cluster design, 565 community clusters, community and IDP-camp settings. All analyses honor the design: state strata, community clusters, linearized variances.</a:t>
             </a:r>
           </a:p>
         </p:txBody>
@@ -6586,7 +6586,7 @@
             </a:pPr>
             <a:r>
               <a:rPr sz="2000"/>
-              <a:t>1,729 adults, January–March 2024 (of the 1,774 in the previous talk)</a:t>
+              <a:t>1,729 adults, May–October 2025 (of the 1,774 in the previous talk)</a:t>
             </a:r>
           </a:p>
           <a:p>

</xml_diff>